<commit_message>
update read me file
</commit_message>
<xml_diff>
--- a/Presentation1.pptx
+++ b/Presentation1.pptx
@@ -260,7 +260,7 @@
           <a:p>
             <a:fld id="{9CE17C9D-C25B-4DD7-8E0F-A0CFC684C607}" type="datetimeFigureOut">
               <a:rPr lang="en-US" smtClean="0"/>
-              <a:t>11/21/2025</a:t>
+              <a:t>6/14/2026</a:t>
             </a:fld>
             <a:endParaRPr lang="en-US"/>
           </a:p>
@@ -458,7 +458,7 @@
           <a:p>
             <a:fld id="{9CE17C9D-C25B-4DD7-8E0F-A0CFC684C607}" type="datetimeFigureOut">
               <a:rPr lang="en-US" smtClean="0"/>
-              <a:t>11/21/2025</a:t>
+              <a:t>6/14/2026</a:t>
             </a:fld>
             <a:endParaRPr lang="en-US"/>
           </a:p>
@@ -666,7 +666,7 @@
           <a:p>
             <a:fld id="{9CE17C9D-C25B-4DD7-8E0F-A0CFC684C607}" type="datetimeFigureOut">
               <a:rPr lang="en-US" smtClean="0"/>
-              <a:t>11/21/2025</a:t>
+              <a:t>6/14/2026</a:t>
             </a:fld>
             <a:endParaRPr lang="en-US"/>
           </a:p>
@@ -864,7 +864,7 @@
           <a:p>
             <a:fld id="{9CE17C9D-C25B-4DD7-8E0F-A0CFC684C607}" type="datetimeFigureOut">
               <a:rPr lang="en-US" smtClean="0"/>
-              <a:t>11/21/2025</a:t>
+              <a:t>6/14/2026</a:t>
             </a:fld>
             <a:endParaRPr lang="en-US"/>
           </a:p>
@@ -1139,7 +1139,7 @@
           <a:p>
             <a:fld id="{9CE17C9D-C25B-4DD7-8E0F-A0CFC684C607}" type="datetimeFigureOut">
               <a:rPr lang="en-US" smtClean="0"/>
-              <a:t>11/21/2025</a:t>
+              <a:t>6/14/2026</a:t>
             </a:fld>
             <a:endParaRPr lang="en-US"/>
           </a:p>
@@ -1404,7 +1404,7 @@
           <a:p>
             <a:fld id="{9CE17C9D-C25B-4DD7-8E0F-A0CFC684C607}" type="datetimeFigureOut">
               <a:rPr lang="en-US" smtClean="0"/>
-              <a:t>11/21/2025</a:t>
+              <a:t>6/14/2026</a:t>
             </a:fld>
             <a:endParaRPr lang="en-US"/>
           </a:p>
@@ -1816,7 +1816,7 @@
           <a:p>
             <a:fld id="{9CE17C9D-C25B-4DD7-8E0F-A0CFC684C607}" type="datetimeFigureOut">
               <a:rPr lang="en-US" smtClean="0"/>
-              <a:t>11/21/2025</a:t>
+              <a:t>6/14/2026</a:t>
             </a:fld>
             <a:endParaRPr lang="en-US"/>
           </a:p>
@@ -1957,7 +1957,7 @@
           <a:p>
             <a:fld id="{9CE17C9D-C25B-4DD7-8E0F-A0CFC684C607}" type="datetimeFigureOut">
               <a:rPr lang="en-US" smtClean="0"/>
-              <a:t>11/21/2025</a:t>
+              <a:t>6/14/2026</a:t>
             </a:fld>
             <a:endParaRPr lang="en-US"/>
           </a:p>
@@ -2070,7 +2070,7 @@
           <a:p>
             <a:fld id="{9CE17C9D-C25B-4DD7-8E0F-A0CFC684C607}" type="datetimeFigureOut">
               <a:rPr lang="en-US" smtClean="0"/>
-              <a:t>11/21/2025</a:t>
+              <a:t>6/14/2026</a:t>
             </a:fld>
             <a:endParaRPr lang="en-US"/>
           </a:p>
@@ -2381,7 +2381,7 @@
           <a:p>
             <a:fld id="{9CE17C9D-C25B-4DD7-8E0F-A0CFC684C607}" type="datetimeFigureOut">
               <a:rPr lang="en-US" smtClean="0"/>
-              <a:t>11/21/2025</a:t>
+              <a:t>6/14/2026</a:t>
             </a:fld>
             <a:endParaRPr lang="en-US"/>
           </a:p>
@@ -2669,7 +2669,7 @@
           <a:p>
             <a:fld id="{9CE17C9D-C25B-4DD7-8E0F-A0CFC684C607}" type="datetimeFigureOut">
               <a:rPr lang="en-US" smtClean="0"/>
-              <a:t>11/21/2025</a:t>
+              <a:t>6/14/2026</a:t>
             </a:fld>
             <a:endParaRPr lang="en-US"/>
           </a:p>
@@ -2910,7 +2910,7 @@
           <a:p>
             <a:fld id="{9CE17C9D-C25B-4DD7-8E0F-A0CFC684C607}" type="datetimeFigureOut">
               <a:rPr lang="en-US" smtClean="0"/>
-              <a:t>11/21/2025</a:t>
+              <a:t>6/14/2026</a:t>
             </a:fld>
             <a:endParaRPr lang="en-US"/>
           </a:p>
@@ -4005,121 +4005,6 @@
       </p:cxnSp>
       <p:cxnSp>
         <p:nvCxnSpPr>
-          <p:cNvPr id="42" name="Straight Connector 41">
-            <a:extLst>
-              <a:ext uri="{FF2B5EF4-FFF2-40B4-BE49-F238E27FC236}">
-                <a16:creationId xmlns:a16="http://schemas.microsoft.com/office/drawing/2014/main" id="{98EE57F5-F89E-6B5B-CE42-EBB17EA5DCDE}"/>
-              </a:ext>
-            </a:extLst>
-          </p:cNvPr>
-          <p:cNvCxnSpPr/>
-          <p:nvPr/>
-        </p:nvCxnSpPr>
-        <p:spPr>
-          <a:xfrm>
-            <a:off x="10364636" y="4024223"/>
-            <a:ext cx="0" cy="1048109"/>
-          </a:xfrm>
-          <a:prstGeom prst="line">
-            <a:avLst/>
-          </a:prstGeom>
-        </p:spPr>
-        <p:style>
-          <a:lnRef idx="1">
-            <a:schemeClr val="accent1"/>
-          </a:lnRef>
-          <a:fillRef idx="0">
-            <a:schemeClr val="accent1"/>
-          </a:fillRef>
-          <a:effectRef idx="0">
-            <a:schemeClr val="accent1"/>
-          </a:effectRef>
-          <a:fontRef idx="minor">
-            <a:schemeClr val="tx1"/>
-          </a:fontRef>
-        </p:style>
-      </p:cxnSp>
-      <p:cxnSp>
-        <p:nvCxnSpPr>
-          <p:cNvPr id="43" name="Straight Connector 42">
-            <a:extLst>
-              <a:ext uri="{FF2B5EF4-FFF2-40B4-BE49-F238E27FC236}">
-                <a16:creationId xmlns:a16="http://schemas.microsoft.com/office/drawing/2014/main" id="{80637EAF-7A5B-3354-5CBF-F621D249FFDE}"/>
-              </a:ext>
-            </a:extLst>
-          </p:cNvPr>
-          <p:cNvCxnSpPr>
-            <a:cxnSpLocks/>
-          </p:cNvCxnSpPr>
-          <p:nvPr/>
-        </p:nvCxnSpPr>
-        <p:spPr>
-          <a:xfrm flipH="1" flipV="1">
-            <a:off x="1742536" y="5072332"/>
-            <a:ext cx="8622100" cy="1438"/>
-          </a:xfrm>
-          <a:prstGeom prst="line">
-            <a:avLst/>
-          </a:prstGeom>
-        </p:spPr>
-        <p:style>
-          <a:lnRef idx="1">
-            <a:schemeClr val="accent1"/>
-          </a:lnRef>
-          <a:fillRef idx="0">
-            <a:schemeClr val="accent1"/>
-          </a:fillRef>
-          <a:effectRef idx="0">
-            <a:schemeClr val="accent1"/>
-          </a:effectRef>
-          <a:fontRef idx="minor">
-            <a:schemeClr val="tx1"/>
-          </a:fontRef>
-        </p:style>
-      </p:cxnSp>
-      <p:cxnSp>
-        <p:nvCxnSpPr>
-          <p:cNvPr id="46" name="Straight Arrow Connector 45">
-            <a:extLst>
-              <a:ext uri="{FF2B5EF4-FFF2-40B4-BE49-F238E27FC236}">
-                <a16:creationId xmlns:a16="http://schemas.microsoft.com/office/drawing/2014/main" id="{77036FEB-DD9E-D28B-8574-30D68A871A77}"/>
-              </a:ext>
-            </a:extLst>
-          </p:cNvPr>
-          <p:cNvCxnSpPr>
-            <a:cxnSpLocks/>
-          </p:cNvCxnSpPr>
-          <p:nvPr/>
-        </p:nvCxnSpPr>
-        <p:spPr>
-          <a:xfrm flipV="1">
-            <a:off x="1742536" y="4024223"/>
-            <a:ext cx="0" cy="1048109"/>
-          </a:xfrm>
-          <a:prstGeom prst="straightConnector1">
-            <a:avLst/>
-          </a:prstGeom>
-          <a:ln>
-            <a:tailEnd type="triangle"/>
-          </a:ln>
-        </p:spPr>
-        <p:style>
-          <a:lnRef idx="1">
-            <a:schemeClr val="accent1"/>
-          </a:lnRef>
-          <a:fillRef idx="0">
-            <a:schemeClr val="accent1"/>
-          </a:fillRef>
-          <a:effectRef idx="0">
-            <a:schemeClr val="accent1"/>
-          </a:effectRef>
-          <a:fontRef idx="minor">
-            <a:schemeClr val="tx1"/>
-          </a:fontRef>
-        </p:style>
-      </p:cxnSp>
-      <p:cxnSp>
-        <p:nvCxnSpPr>
           <p:cNvPr id="50" name="Straight Connector 49">
             <a:extLst>
               <a:ext uri="{FF2B5EF4-FFF2-40B4-BE49-F238E27FC236}">
@@ -4457,8 +4342,8 @@
         </p:nvSpPr>
         <p:spPr>
           <a:xfrm>
-            <a:off x="8363311" y="2994806"/>
-            <a:ext cx="940277" cy="405441"/>
+            <a:off x="8190781" y="3000556"/>
+            <a:ext cx="1250829" cy="405441"/>
           </a:xfrm>
           <a:prstGeom prst="rect">
             <a:avLst/>
@@ -4491,7 +4376,7 @@
             <a:pPr algn="ctr"/>
             <a:r>
               <a:rPr lang="en-US" dirty="0"/>
-              <a:t>Git soft</a:t>
+              <a:t>Git Push</a:t>
             </a:r>
           </a:p>
         </p:txBody>
@@ -4545,59 +4430,6 @@
             <a:r>
               <a:rPr lang="en-US" dirty="0"/>
               <a:t>git reset</a:t>
-            </a:r>
-          </a:p>
-        </p:txBody>
-      </p:sp>
-      <p:sp>
-        <p:nvSpPr>
-          <p:cNvPr id="8" name="Rectangle 7">
-            <a:extLst>
-              <a:ext uri="{FF2B5EF4-FFF2-40B4-BE49-F238E27FC236}">
-                <a16:creationId xmlns:a16="http://schemas.microsoft.com/office/drawing/2014/main" id="{650A8AD1-DF18-0114-4707-C38B84AC3778}"/>
-              </a:ext>
-            </a:extLst>
-          </p:cNvPr>
-          <p:cNvSpPr/>
-          <p:nvPr/>
-        </p:nvSpPr>
-        <p:spPr>
-          <a:xfrm>
-            <a:off x="5588121" y="5154281"/>
-            <a:ext cx="1015757" cy="623980"/>
-          </a:xfrm>
-          <a:prstGeom prst="rect">
-            <a:avLst/>
-          </a:prstGeom>
-          <a:solidFill>
-            <a:schemeClr val="accent2"/>
-          </a:solidFill>
-          <a:ln>
-            <a:noFill/>
-          </a:ln>
-        </p:spPr>
-        <p:style>
-          <a:lnRef idx="2">
-            <a:schemeClr val="dk1"/>
-          </a:lnRef>
-          <a:fillRef idx="1">
-            <a:schemeClr val="lt1"/>
-          </a:fillRef>
-          <a:effectRef idx="0">
-            <a:schemeClr val="dk1"/>
-          </a:effectRef>
-          <a:fontRef idx="minor">
-            <a:schemeClr val="dk1"/>
-          </a:fontRef>
-        </p:style>
-        <p:txBody>
-          <a:bodyPr rtlCol="0" anchor="ctr"/>
-          <a:lstStyle/>
-          <a:p>
-            <a:pPr algn="ctr"/>
-            <a:r>
-              <a:rPr lang="en-US" b="1" dirty="0"/>
-              <a:t>git reset hard</a:t>
             </a:r>
           </a:p>
         </p:txBody>

</xml_diff>